<commit_message>
Unify header and footer across all pages, update student & faculty contacts (Harsh Srivastava, Dhananjay Sharma Sir, Dr. Manas Pandey Sir), fix 100% full content width, and add skeleton loaders
</commit_message>
<xml_diff>
--- a/assets/SIH-2026-Idea-Presentation-Template.pptx
+++ b/assets/SIH-2026-Idea-Presentation-Template.pptx
@@ -5699,7 +5699,7 @@
         </p:blipFill>
         <p:spPr>
           <a:xfrm>
-            <a:off x="6854891" y="1715881"/>
+            <a:off x="6860163" y="2255255"/>
             <a:ext cx="3203509" cy="3426237"/>
           </a:xfrm>
           <a:prstGeom prst="rect">
@@ -5719,7 +5719,7 @@
         </p:nvSpPr>
         <p:spPr>
           <a:xfrm>
-            <a:off x="1389580" y="1137027"/>
+            <a:off x="1556319" y="863921"/>
             <a:ext cx="8534400" cy="1752600"/>
           </a:xfrm>
         </p:spPr>
@@ -5768,8 +5768,8 @@
         </p:nvSpPr>
         <p:spPr>
           <a:xfrm>
-            <a:off x="3401608" y="218045"/>
-            <a:ext cx="6160587" cy="930922"/>
+            <a:off x="2778208" y="189132"/>
+            <a:ext cx="7043789" cy="930922"/>
           </a:xfrm>
         </p:spPr>
         <p:txBody>
@@ -5783,7 +5783,7 @@
                 </a:solidFill>
                 <a:latin typeface="Garamond" panose="02020404030301010803" pitchFamily="18" charset="0"/>
               </a:rPr>
-              <a:t>SMART INDIA HACKATHON 2026</a:t>
+              <a:t>UIT INTERNAL HACKATHON - SIH 2026</a:t>
             </a:r>
             <a:endParaRPr lang="en-IN" sz="4000" b="1" dirty="0">
               <a:solidFill>
@@ -5952,10 +5952,10 @@
       </p:pic>
       <p:pic>
         <p:nvPicPr>
-          <p:cNvPr id="1026" name="Picture 2" descr="United Institute of Technology">
+          <p:cNvPr id="11" name="Picture 2" descr="United Institute of Technology">
             <a:extLst>
               <a:ext uri="{FF2B5EF4-FFF2-40B4-BE49-F238E27FC236}">
-                <a16:creationId xmlns:a16="http://schemas.microsoft.com/office/drawing/2014/main" id="{5A286FB2-B593-478E-A4C5-81FDC96A72B7}"/>
+                <a16:creationId xmlns:a16="http://schemas.microsoft.com/office/drawing/2014/main" id="{F9FB5B73-D3AA-4E05-BE36-1752F7062681}"/>
               </a:ext>
             </a:extLst>
           </p:cNvPr>

</xml_diff>